<commit_message>
Add recorded narration and timings to benefits slides
</commit_message>
<xml_diff>
--- a/presentation/AI_Coding_Agents_Benefits_Final.pptx
+++ b/presentation/AI_Coding_Agents_Benefits_Final.pptx
@@ -112,6 +112,11 @@
       </a:defRPr>
     </a:lvl9pPr>
   </p:defaultTextStyle>
+  <p:extLst>
+    <p:ext uri="{EFAFB233-063F-42B5-8137-9DF3F51BA10A}">
+      <p15:sldGuideLst xmlns:p15="http://schemas.microsoft.com/office/powerpoint/2012/main"/>
+    </p:ext>
+  </p:extLst>
 </p:presentation>
 </file>
 
@@ -331,45 +336,51 @@
           <a:lstStyle/>
           <a:p>
             <a:r>
+              <a:rPr dirty="0"/>
               <a:t>Speaker: Wumaier Kutelike</a:t>
             </a:r>
           </a:p>
           <a:p>
-            <a:endParaRPr/>
-          </a:p>
-          <a:p>
-            <a:r>
+            <a:endParaRPr dirty="0"/>
+          </a:p>
+          <a:p>
+            <a:r>
+              <a:rPr dirty="0"/>
               <a:t>SCRIPT</a:t>
             </a:r>
           </a:p>
           <a:p>
             <a:r>
+              <a:rPr dirty="0"/>
               <a:t>Hello, our names are Wumaier and Sebastian. Today, we will explain how AI coding agents are changing software development, including their practical uses, potential benefits, and risks.</a:t>
             </a:r>
           </a:p>
           <a:p>
-            <a:endParaRPr/>
-          </a:p>
-          <a:p>
-            <a:endParaRPr/>
-          </a:p>
-          <a:p>
-            <a:r>
+            <a:endParaRPr dirty="0"/>
+          </a:p>
+          <a:p>
+            <a:endParaRPr dirty="0"/>
+          </a:p>
+          <a:p>
+            <a:r>
+              <a:rPr dirty="0"/>
               <a:t>SOURCES AND CONTEXT (not spoken)</a:t>
             </a:r>
           </a:p>
           <a:p>
             <a:r>
+              <a:rPr dirty="0"/>
               <a:t>Cover: AI-generated decorative illustration. It is not evidence of a real event.</a:t>
             </a:r>
           </a:p>
           <a:p>
             <a:r>
+              <a:rPr dirty="0"/>
               <a:t>Accessed 17 October 2026 UTC.</a:t>
             </a:r>
           </a:p>
           <a:p>
-            <a:endParaRPr/>
+            <a:endParaRPr dirty="0"/>
           </a:p>
         </p:txBody>
       </p:sp>
@@ -445,60 +456,101 @@
           <a:lstStyle/>
           <a:p>
             <a:r>
+              <a:rPr dirty="0"/>
               <a:t>Speaker: Wumaier Kutelike</a:t>
             </a:r>
           </a:p>
           <a:p>
-            <a:endParaRPr/>
-          </a:p>
-          <a:p>
-            <a:r>
+            <a:endParaRPr dirty="0"/>
+          </a:p>
+          <a:p>
+            <a:r>
+              <a:rPr dirty="0"/>
               <a:t>SCRIPT</a:t>
             </a:r>
           </a:p>
           <a:p>
             <a:r>
+              <a:rPr dirty="0"/>
               <a:t>On June 30, 2026, GitHub announced that Copilot Agent became available inside JetBrains AI Assistant. According to GitHub, developers can select Copilot from the agent picker, choose a supported model, and adjust the reasoning level. The agent can examine a project, propose changes, run commands, and work through multistep tasks.</a:t>
             </a:r>
           </a:p>
           <a:p>
-            <a:endParaRPr/>
-          </a:p>
-          <a:p>
-            <a:endParaRPr/>
-          </a:p>
-          <a:p>
-            <a:r>
+            <a:endParaRPr dirty="0"/>
+          </a:p>
+          <a:p>
+            <a:endParaRPr dirty="0"/>
+          </a:p>
+          <a:p>
+            <a:r>
+              <a:rPr dirty="0"/>
               <a:t>SOURCES AND CONTEXT (not spoken)</a:t>
             </a:r>
           </a:p>
           <a:p>
             <a:r>
-              <a:t>GitHub Changelog, 30 June 2026. https://github.blog/changelog/2026-06-30-copilot-agent-is-now-available-in-jetbrains-ai-assistant/</a:t>
-            </a:r>
-          </a:p>
-          <a:p>
-            <a:r>
-              <a:t>JetBrains, June 2026. https://blog.jetbrains.com/ai/2026/06/github-copilot-now-an-integrated-agent/</a:t>
-            </a:r>
-          </a:p>
-          <a:p>
-            <a:r>
-              <a:t>Screenshot: https://admin.blog.jetbrains.com/wp-content/uploads/2026/06/image-24.png</a:t>
-            </a:r>
-          </a:p>
-          <a:p>
-            <a:r>
+              <a:rPr dirty="0"/>
+              <a:t>GitHub Changelog, 30 June 2026. https://</a:t>
+            </a:r>
+            <a:r>
+              <a:rPr dirty="0" err="1"/>
+              <a:t>github.blog</a:t>
+            </a:r>
+            <a:r>
+              <a:rPr dirty="0"/>
+              <a:t>/changelog/2026-06-30-copilot-agent-is-now-available-in-jetbrains-ai-assistant/</a:t>
+            </a:r>
+          </a:p>
+          <a:p>
+            <a:r>
+              <a:rPr dirty="0"/>
+              <a:t>JetBrains, June 2026. https://</a:t>
+            </a:r>
+            <a:r>
+              <a:rPr dirty="0" err="1"/>
+              <a:t>blog.jetbrains.com</a:t>
+            </a:r>
+            <a:r>
+              <a:rPr dirty="0"/>
+              <a:t>/ai/2026/06/</a:t>
+            </a:r>
+            <a:r>
+              <a:rPr dirty="0" err="1"/>
+              <a:t>github</a:t>
+            </a:r>
+            <a:r>
+              <a:rPr dirty="0"/>
+              <a:t>-copilot-now-an-integrated-agent/</a:t>
+            </a:r>
+          </a:p>
+          <a:p>
+            <a:r>
+              <a:rPr dirty="0"/>
+              <a:t>Screenshot: https://</a:t>
+            </a:r>
+            <a:r>
+              <a:rPr dirty="0" err="1"/>
+              <a:t>admin.blog.jetbrains.com</a:t>
+            </a:r>
+            <a:r>
+              <a:rPr dirty="0"/>
+              <a:t>/wp-content/uploads/2026/06/image-24.png</a:t>
+            </a:r>
+          </a:p>
+          <a:p>
+            <a:r>
+              <a:rPr dirty="0"/>
               <a:t>The event is native integration, not Copilot’s first availability in JetBrains. It previously existed through a plugin and ACP. The significance statement summarizes the announced IDE workflow, not a measured productivity effect.</a:t>
             </a:r>
           </a:p>
           <a:p>
             <a:r>
+              <a:rPr dirty="0"/>
               <a:t>Accessed 17 October 2026 UTC.</a:t>
             </a:r>
           </a:p>
           <a:p>
-            <a:endParaRPr/>
+            <a:endParaRPr dirty="0"/>
           </a:p>
         </p:txBody>
       </p:sp>
@@ -574,55 +626,111 @@
           <a:lstStyle/>
           <a:p>
             <a:r>
+              <a:rPr dirty="0"/>
               <a:t>Speaker: Wumaier Kutelike</a:t>
             </a:r>
           </a:p>
           <a:p>
-            <a:endParaRPr/>
-          </a:p>
-          <a:p>
-            <a:r>
+            <a:endParaRPr dirty="0"/>
+          </a:p>
+          <a:p>
+            <a:r>
+              <a:rPr dirty="0"/>
               <a:t>SCRIPT</a:t>
             </a:r>
           </a:p>
           <a:p>
             <a:r>
+              <a:rPr dirty="0"/>
               <a:t>For this presentation, an AI coding agent means an AI tool that uses project context and development tools to complete several steps toward a programming goal. It goes beyond simply suggesting the next line of code.</a:t>
             </a:r>
           </a:p>
           <a:p>
-            <a:endParaRPr/>
-          </a:p>
-          <a:p>
-            <a:endParaRPr/>
-          </a:p>
-          <a:p>
-            <a:r>
+            <a:endParaRPr dirty="0"/>
+          </a:p>
+          <a:p>
+            <a:endParaRPr dirty="0"/>
+          </a:p>
+          <a:p>
+            <a:r>
+              <a:rPr dirty="0"/>
               <a:t>SOURCES AND CONTEXT (not spoken)</a:t>
             </a:r>
           </a:p>
           <a:p>
             <a:r>
-              <a:t>GitHub Docs. https://docs.github.com/en/copilot/how-tos/copilot-in-your-ide/use-copilot-agents/use-agent-mode</a:t>
-            </a:r>
-          </a:p>
-          <a:p>
-            <a:r>
-              <a:t>https://docs.github.com/en/copilot/how-tos/copilot-in-your-ide/chat-with-copilot/chat-in-ide</a:t>
-            </a:r>
-          </a:p>
-          <a:p>
-            <a:r>
+              <a:rPr dirty="0"/>
+              <a:t>GitHub Docs. https://</a:t>
+            </a:r>
+            <a:r>
+              <a:rPr dirty="0" err="1"/>
+              <a:t>docs.github.com</a:t>
+            </a:r>
+            <a:r>
+              <a:rPr dirty="0"/>
+              <a:t>/</a:t>
+            </a:r>
+            <a:r>
+              <a:rPr dirty="0" err="1"/>
+              <a:t>en</a:t>
+            </a:r>
+            <a:r>
+              <a:rPr dirty="0"/>
+              <a:t>/copilot/how-</a:t>
+            </a:r>
+            <a:r>
+              <a:rPr dirty="0" err="1"/>
+              <a:t>tos</a:t>
+            </a:r>
+            <a:r>
+              <a:rPr dirty="0"/>
+              <a:t>/copilot-in-your-ide/use-copilot-agents/use-agent-mode</a:t>
+            </a:r>
+          </a:p>
+          <a:p>
+            <a:r>
+              <a:rPr dirty="0"/>
+              <a:t>https://</a:t>
+            </a:r>
+            <a:r>
+              <a:rPr dirty="0" err="1"/>
+              <a:t>docs.github.com</a:t>
+            </a:r>
+            <a:r>
+              <a:rPr dirty="0"/>
+              <a:t>/</a:t>
+            </a:r>
+            <a:r>
+              <a:rPr dirty="0" err="1"/>
+              <a:t>en</a:t>
+            </a:r>
+            <a:r>
+              <a:rPr dirty="0"/>
+              <a:t>/copilot/how-</a:t>
+            </a:r>
+            <a:r>
+              <a:rPr dirty="0" err="1"/>
+              <a:t>tos</a:t>
+            </a:r>
+            <a:r>
+              <a:rPr dirty="0"/>
+              <a:t>/copilot-in-your-ide/chat-with-copilot/chat-in-ide</a:t>
+            </a:r>
+          </a:p>
+          <a:p>
+            <a:r>
+              <a:rPr dirty="0"/>
               <a:t>Comparison concerns inline autocomplete and an agent task workflow. Both can use context. Tool access and permissions vary by editor and settings.</a:t>
             </a:r>
           </a:p>
           <a:p>
             <a:r>
+              <a:rPr dirty="0"/>
               <a:t>Accessed 17 October 2026 UTC.</a:t>
             </a:r>
           </a:p>
           <a:p>
-            <a:endParaRPr/>
+            <a:endParaRPr dirty="0"/>
           </a:p>
         </p:txBody>
       </p:sp>
@@ -698,50 +806,81 @@
           <a:lstStyle/>
           <a:p>
             <a:r>
+              <a:rPr dirty="0"/>
               <a:t>Speaker: Wumaier Kutelike</a:t>
             </a:r>
           </a:p>
           <a:p>
-            <a:endParaRPr/>
-          </a:p>
-          <a:p>
-            <a:r>
+            <a:endParaRPr dirty="0"/>
+          </a:p>
+          <a:p>
+            <a:r>
+              <a:rPr dirty="0"/>
               <a:t>SCRIPT</a:t>
             </a:r>
           </a:p>
           <a:p>
             <a:r>
+              <a:rPr dirty="0"/>
               <a:t>For example, a developer can ask an agent to fix a small bug. The agent may inspect the project, suggest a change, run relevant commands, and revise its work after receiving feedback.</a:t>
             </a:r>
           </a:p>
           <a:p>
-            <a:endParaRPr/>
-          </a:p>
-          <a:p>
-            <a:endParaRPr/>
-          </a:p>
-          <a:p>
-            <a:r>
+            <a:endParaRPr dirty="0"/>
+          </a:p>
+          <a:p>
+            <a:endParaRPr dirty="0"/>
+          </a:p>
+          <a:p>
+            <a:r>
+              <a:rPr dirty="0"/>
               <a:t>SOURCES AND CONTEXT (not spoken)</a:t>
             </a:r>
           </a:p>
           <a:p>
             <a:r>
-              <a:t>GitHub Docs. https://docs.github.com/en/copilot/how-tos/copilot-in-your-ide/use-copilot-agents/use-agent-mode</a:t>
-            </a:r>
-          </a:p>
-          <a:p>
-            <a:r>
+              <a:rPr dirty="0"/>
+              <a:t>GitHub Docs. https://</a:t>
+            </a:r>
+            <a:r>
+              <a:rPr dirty="0" err="1"/>
+              <a:t>docs.github.com</a:t>
+            </a:r>
+            <a:r>
+              <a:rPr dirty="0"/>
+              <a:t>/</a:t>
+            </a:r>
+            <a:r>
+              <a:rPr dirty="0" err="1"/>
+              <a:t>en</a:t>
+            </a:r>
+            <a:r>
+              <a:rPr dirty="0"/>
+              <a:t>/copilot/how-</a:t>
+            </a:r>
+            <a:r>
+              <a:rPr dirty="0" err="1"/>
+              <a:t>tos</a:t>
+            </a:r>
+            <a:r>
+              <a:rPr dirty="0"/>
+              <a:t>/copilot-in-your-ide/use-copilot-agents/use-agent-mode</a:t>
+            </a:r>
+          </a:p>
+          <a:p>
+            <a:r>
+              <a:rPr dirty="0"/>
               <a:t>The empty-input crash and regression test form an illustrative example created for explanation. No such bug fix was executed or measured by this presentation. An agent may propose commands, subject to its configured permissions.</a:t>
             </a:r>
           </a:p>
           <a:p>
             <a:r>
+              <a:rPr dirty="0"/>
               <a:t>Accessed 17 October 2026 UTC.</a:t>
             </a:r>
           </a:p>
           <a:p>
-            <a:endParaRPr/>
+            <a:endParaRPr dirty="0"/>
           </a:p>
         </p:txBody>
       </p:sp>
@@ -817,68 +956,126 @@
           <a:lstStyle/>
           <a:p>
             <a:r>
+              <a:rPr dirty="0"/>
               <a:t>Speaker: Wumaier Kutelike</a:t>
             </a:r>
           </a:p>
           <a:p>
-            <a:endParaRPr/>
-          </a:p>
-          <a:p>
-            <a:r>
+            <a:endParaRPr dirty="0"/>
+          </a:p>
+          <a:p>
+            <a:r>
+              <a:rPr dirty="0"/>
               <a:t>SCRIPT</a:t>
             </a:r>
           </a:p>
           <a:p>
             <a:r>
+              <a:rPr dirty="0"/>
               <a:t>Agents may also help with refactoring, writing tests, and updating documentation.</a:t>
             </a:r>
           </a:p>
           <a:p>
-            <a:endParaRPr/>
-          </a:p>
-          <a:p>
-            <a:r>
+            <a:endParaRPr dirty="0"/>
+          </a:p>
+          <a:p>
+            <a:r>
+              <a:rPr dirty="0"/>
               <a:t>These capabilities may reduce repetitive work, provide developers with a useful starting point, and reduce switching between tools. However, these are potential benefits, not guaranteed improvements.</a:t>
             </a:r>
           </a:p>
           <a:p>
-            <a:endParaRPr/>
-          </a:p>
-          <a:p>
-            <a:r>
+            <a:endParaRPr dirty="0"/>
+          </a:p>
+          <a:p>
+            <a:r>
+              <a:rPr dirty="0"/>
               <a:t>HANDOVER: continue directly to Sebastian’s risk section. No extra handover sentence is needed.</a:t>
             </a:r>
           </a:p>
           <a:p>
-            <a:endParaRPr/>
-          </a:p>
-          <a:p>
-            <a:r>
+            <a:endParaRPr dirty="0"/>
+          </a:p>
+          <a:p>
+            <a:r>
+              <a:rPr dirty="0"/>
               <a:t>SOURCES AND CONTEXT (not spoken)</a:t>
             </a:r>
           </a:p>
           <a:p>
             <a:r>
-              <a:t>GitHub Docs. https://docs.github.com/en/copilot/how-tos/copilot-in-your-ide/use-copilot-agents/use-agent-mode</a:t>
-            </a:r>
-          </a:p>
-          <a:p>
-            <a:r>
-              <a:t>https://docs.github.com/en/copilot/how-tos/copilot-in-your-ide/chat-with-copilot/chat-in-ide</a:t>
-            </a:r>
-          </a:p>
-          <a:p>
-            <a:r>
+              <a:rPr dirty="0"/>
+              <a:t>GitHub Docs. https://</a:t>
+            </a:r>
+            <a:r>
+              <a:rPr dirty="0" err="1"/>
+              <a:t>docs.github.com</a:t>
+            </a:r>
+            <a:r>
+              <a:rPr dirty="0"/>
+              <a:t>/</a:t>
+            </a:r>
+            <a:r>
+              <a:rPr dirty="0" err="1"/>
+              <a:t>en</a:t>
+            </a:r>
+            <a:r>
+              <a:rPr dirty="0"/>
+              <a:t>/copilot/how-</a:t>
+            </a:r>
+            <a:r>
+              <a:rPr dirty="0" err="1"/>
+              <a:t>tos</a:t>
+            </a:r>
+            <a:r>
+              <a:rPr dirty="0"/>
+              <a:t>/copilot-in-your-ide/use-copilot-agents/use-agent-mode</a:t>
+            </a:r>
+          </a:p>
+          <a:p>
+            <a:r>
+              <a:rPr dirty="0"/>
+              <a:t>https://</a:t>
+            </a:r>
+            <a:r>
+              <a:rPr dirty="0" err="1"/>
+              <a:t>docs.github.com</a:t>
+            </a:r>
+            <a:r>
+              <a:rPr dirty="0"/>
+              <a:t>/</a:t>
+            </a:r>
+            <a:r>
+              <a:rPr dirty="0" err="1"/>
+              <a:t>en</a:t>
+            </a:r>
+            <a:r>
+              <a:rPr dirty="0"/>
+              <a:t>/copilot/how-</a:t>
+            </a:r>
+            <a:r>
+              <a:rPr dirty="0" err="1"/>
+              <a:t>tos</a:t>
+            </a:r>
+            <a:r>
+              <a:rPr dirty="0"/>
+              <a:t>/copilot-in-your-ide/chat-with-copilot/chat-in-ide</a:t>
+            </a:r>
+          </a:p>
+          <a:p>
+            <a:r>
+              <a:rPr dirty="0"/>
               <a:t>The possible benefits are reasoned implications of supported workflows. They are not universal guarantees or a quantified speedup.</a:t>
             </a:r>
           </a:p>
           <a:p>
             <a:r>
+              <a:rPr dirty="0"/>
               <a:t>Accessed 17 October 2026 UTC.</a:t>
             </a:r>
           </a:p>
           <a:p>
-            <a:endParaRPr/>
+            <a:endParaRPr dirty="0"/>
           </a:p>
         </p:txBody>
       </p:sp>
@@ -3144,7 +3341,7 @@
           <p:nvPr/>
         </p:nvPicPr>
         <p:blipFill>
-          <a:blip r:embed="rId3"/>
+          <a:blip r:embed="rId5"/>
           <a:srcRect t="27" b="27"/>
           <a:stretch>
             <a:fillRect/>
@@ -3529,6 +3726,43 @@
           </a:p>
         </p:txBody>
       </p:sp>
+      <p:pic>
+        <p:nvPicPr>
+          <p:cNvPr id="24" name="Audio 23">
+            <a:extLst>
+              <a:ext uri="{FF2B5EF4-FFF2-40B4-BE49-F238E27FC236}">
+                <a16:creationId xmlns:a16="http://schemas.microsoft.com/office/drawing/2014/main" id="{032866E3-2150-ADFB-36DB-952E791ECD69}"/>
+              </a:ext>
+            </a:extLst>
+          </p:cNvPr>
+          <p:cNvPicPr>
+            <a:picLocks noChangeAspect="1"/>
+          </p:cNvPicPr>
+          <p:nvPr>
+            <a:audioFile r:link="rId2"/>
+            <p:extLst>
+              <p:ext uri="{DAA4B4D4-6D71-4841-9C94-3DE7FCFB9230}">
+                <p14:media xmlns:p14="http://schemas.microsoft.com/office/powerpoint/2010/main" r:embed="rId1"/>
+              </p:ext>
+            </p:extLst>
+          </p:nvPr>
+        </p:nvPicPr>
+        <p:blipFill>
+          <a:blip r:embed="rId6"/>
+          <a:stretch>
+            <a:fillRect/>
+          </a:stretch>
+        </p:blipFill>
+        <p:spPr>
+          <a:xfrm>
+            <a:off x="11163300" y="5829300"/>
+            <a:ext cx="812800" cy="812800"/>
+          </a:xfrm>
+          <a:prstGeom prst="rect">
+            <a:avLst/>
+          </a:prstGeom>
+        </p:spPr>
+      </p:pic>
     </p:spTree>
     <p:extLst>
       <p:ext uri="{BB962C8B-B14F-4D97-AF65-F5344CB8AC3E}">
@@ -3539,6 +3773,101 @@
   <p:clrMapOvr>
     <a:masterClrMapping/>
   </p:clrMapOvr>
+  <mc:AlternateContent xmlns:mc="http://schemas.openxmlformats.org/markup-compatibility/2006">
+    <mc:Choice xmlns:p14="http://schemas.microsoft.com/office/powerpoint/2010/main" Requires="p14">
+      <p:transition spd="slow" p14:dur="2000" advTm="12155"/>
+    </mc:Choice>
+    <mc:Fallback>
+      <p:transition spd="slow" advTm="12155"/>
+    </mc:Fallback>
+  </mc:AlternateContent>
+  <p:timing>
+    <p:tnLst>
+      <p:par>
+        <p:cTn id="1" dur="indefinite" restart="never" nodeType="tmRoot">
+          <p:childTnLst>
+            <p:seq concurrent="1" nextAc="seek">
+              <p:cTn id="2" dur="indefinite" nodeType="mainSeq">
+                <p:childTnLst>
+                  <p:par>
+                    <p:cTn id="3" fill="hold">
+                      <p:stCondLst>
+                        <p:cond delay="indefinite"/>
+                        <p:cond evt="onBegin" delay="0">
+                          <p:tn val="2"/>
+                        </p:cond>
+                      </p:stCondLst>
+                      <p:childTnLst>
+                        <p:par>
+                          <p:cTn id="4" fill="hold">
+                            <p:stCondLst>
+                              <p:cond delay="0"/>
+                            </p:stCondLst>
+                            <p:childTnLst>
+                              <p:par>
+                                <p:cTn id="5" presetID="1" presetClass="mediacall" presetSubtype="0" fill="hold" nodeType="afterEffect">
+                                  <p:stCondLst>
+                                    <p:cond delay="0"/>
+                                  </p:stCondLst>
+                                  <p:childTnLst>
+                                    <p:cmd type="call" cmd="playFrom(0.0)">
+                                      <p:cBhvr>
+                                        <p:cTn id="6" dur="1" fill="hold"/>
+                                        <p:tgtEl>
+                                          <p:spTgt spid="24"/>
+                                        </p:tgtEl>
+                                      </p:cBhvr>
+                                    </p:cmd>
+                                  </p:childTnLst>
+                                </p:cTn>
+                              </p:par>
+                            </p:childTnLst>
+                          </p:cTn>
+                        </p:par>
+                      </p:childTnLst>
+                    </p:cTn>
+                  </p:par>
+                </p:childTnLst>
+              </p:cTn>
+              <p:prevCondLst>
+                <p:cond evt="onPrev" delay="0">
+                  <p:tgtEl>
+                    <p:sldTgt/>
+                  </p:tgtEl>
+                </p:cond>
+              </p:prevCondLst>
+              <p:nextCondLst>
+                <p:cond evt="onNext" delay="0">
+                  <p:tgtEl>
+                    <p:sldTgt/>
+                  </p:tgtEl>
+                </p:cond>
+              </p:nextCondLst>
+            </p:seq>
+            <p:audio isNarration="1">
+              <p:cMediaNode vol="80000" showWhenStopped="0">
+                <p:cTn id="7" fill="hold" display="0">
+                  <p:stCondLst>
+                    <p:cond delay="indefinite"/>
+                  </p:stCondLst>
+                  <p:endCondLst>
+                    <p:cond evt="onStopAudio" delay="0">
+                      <p:tgtEl>
+                        <p:sldTgt/>
+                      </p:tgtEl>
+                    </p:cond>
+                  </p:endCondLst>
+                </p:cTn>
+                <p:tgtEl>
+                  <p:spTgt spid="24"/>
+                </p:tgtEl>
+              </p:cMediaNode>
+            </p:audio>
+          </p:childTnLst>
+        </p:cTn>
+      </p:par>
+    </p:tnLst>
+  </p:timing>
 </p:sld>
 </file>
 
@@ -4039,7 +4368,7 @@
           <p:nvPr/>
         </p:nvPicPr>
         <p:blipFill>
-          <a:blip r:embed="rId3"/>
+          <a:blip r:embed="rId5"/>
           <a:srcRect l="12500" t="33000" r="40500" b="14500"/>
           <a:stretch/>
         </p:blipFill>
@@ -4122,6 +4451,43 @@
           </a:p>
         </p:txBody>
       </p:sp>
+      <p:pic>
+        <p:nvPicPr>
+          <p:cNvPr id="22" name="Audio 21">
+            <a:extLst>
+              <a:ext uri="{FF2B5EF4-FFF2-40B4-BE49-F238E27FC236}">
+                <a16:creationId xmlns:a16="http://schemas.microsoft.com/office/drawing/2014/main" id="{096BC2B3-B536-9BBC-D4A4-E523AC65D78C}"/>
+              </a:ext>
+            </a:extLst>
+          </p:cNvPr>
+          <p:cNvPicPr>
+            <a:picLocks noChangeAspect="1"/>
+          </p:cNvPicPr>
+          <p:nvPr>
+            <a:audioFile r:link="rId2"/>
+            <p:extLst>
+              <p:ext uri="{DAA4B4D4-6D71-4841-9C94-3DE7FCFB9230}">
+                <p14:media xmlns:p14="http://schemas.microsoft.com/office/powerpoint/2010/main" r:embed="rId1"/>
+              </p:ext>
+            </p:extLst>
+          </p:nvPr>
+        </p:nvPicPr>
+        <p:blipFill>
+          <a:blip r:embed="rId6"/>
+          <a:stretch>
+            <a:fillRect/>
+          </a:stretch>
+        </p:blipFill>
+        <p:spPr>
+          <a:xfrm>
+            <a:off x="11163300" y="5829300"/>
+            <a:ext cx="812800" cy="812800"/>
+          </a:xfrm>
+          <a:prstGeom prst="rect">
+            <a:avLst/>
+          </a:prstGeom>
+        </p:spPr>
+      </p:pic>
     </p:spTree>
     <p:extLst>
       <p:ext uri="{BB962C8B-B14F-4D97-AF65-F5344CB8AC3E}">
@@ -4132,6 +4498,101 @@
   <p:clrMapOvr>
     <a:masterClrMapping/>
   </p:clrMapOvr>
+  <mc:AlternateContent xmlns:mc="http://schemas.openxmlformats.org/markup-compatibility/2006">
+    <mc:Choice xmlns:p14="http://schemas.microsoft.com/office/powerpoint/2010/main" Requires="p14">
+      <p:transition spd="slow" p14:dur="2000" advTm="25871"/>
+    </mc:Choice>
+    <mc:Fallback>
+      <p:transition spd="slow" advTm="25871"/>
+    </mc:Fallback>
+  </mc:AlternateContent>
+  <p:timing>
+    <p:tnLst>
+      <p:par>
+        <p:cTn id="1" dur="indefinite" restart="never" nodeType="tmRoot">
+          <p:childTnLst>
+            <p:seq concurrent="1" nextAc="seek">
+              <p:cTn id="2" dur="indefinite" nodeType="mainSeq">
+                <p:childTnLst>
+                  <p:par>
+                    <p:cTn id="3" fill="hold">
+                      <p:stCondLst>
+                        <p:cond delay="indefinite"/>
+                        <p:cond evt="onBegin" delay="0">
+                          <p:tn val="2"/>
+                        </p:cond>
+                      </p:stCondLst>
+                      <p:childTnLst>
+                        <p:par>
+                          <p:cTn id="4" fill="hold">
+                            <p:stCondLst>
+                              <p:cond delay="0"/>
+                            </p:stCondLst>
+                            <p:childTnLst>
+                              <p:par>
+                                <p:cTn id="5" presetID="1" presetClass="mediacall" presetSubtype="0" fill="hold" nodeType="afterEffect">
+                                  <p:stCondLst>
+                                    <p:cond delay="0"/>
+                                  </p:stCondLst>
+                                  <p:childTnLst>
+                                    <p:cmd type="call" cmd="playFrom(0.0)">
+                                      <p:cBhvr>
+                                        <p:cTn id="6" dur="1" fill="hold"/>
+                                        <p:tgtEl>
+                                          <p:spTgt spid="22"/>
+                                        </p:tgtEl>
+                                      </p:cBhvr>
+                                    </p:cmd>
+                                  </p:childTnLst>
+                                </p:cTn>
+                              </p:par>
+                            </p:childTnLst>
+                          </p:cTn>
+                        </p:par>
+                      </p:childTnLst>
+                    </p:cTn>
+                  </p:par>
+                </p:childTnLst>
+              </p:cTn>
+              <p:prevCondLst>
+                <p:cond evt="onPrev" delay="0">
+                  <p:tgtEl>
+                    <p:sldTgt/>
+                  </p:tgtEl>
+                </p:cond>
+              </p:prevCondLst>
+              <p:nextCondLst>
+                <p:cond evt="onNext" delay="0">
+                  <p:tgtEl>
+                    <p:sldTgt/>
+                  </p:tgtEl>
+                </p:cond>
+              </p:nextCondLst>
+            </p:seq>
+            <p:audio isNarration="1">
+              <p:cMediaNode vol="80000" showWhenStopped="0">
+                <p:cTn id="7" fill="hold" display="0">
+                  <p:stCondLst>
+                    <p:cond delay="indefinite"/>
+                  </p:stCondLst>
+                  <p:endCondLst>
+                    <p:cond evt="onStopAudio" delay="0">
+                      <p:tgtEl>
+                        <p:sldTgt/>
+                      </p:tgtEl>
+                    </p:cond>
+                  </p:endCondLst>
+                </p:cTn>
+                <p:tgtEl>
+                  <p:spTgt spid="22"/>
+                </p:tgtEl>
+              </p:cMediaNode>
+            </p:audio>
+          </p:childTnLst>
+        </p:cTn>
+      </p:par>
+    </p:tnLst>
+  </p:timing>
 </p:sld>
 </file>
 
@@ -5150,6 +5611,43 @@
           </a:p>
         </p:txBody>
       </p:sp>
+      <p:pic>
+        <p:nvPicPr>
+          <p:cNvPr id="18" name="Audio 17">
+            <a:extLst>
+              <a:ext uri="{FF2B5EF4-FFF2-40B4-BE49-F238E27FC236}">
+                <a16:creationId xmlns:a16="http://schemas.microsoft.com/office/drawing/2014/main" id="{3408F79C-4E96-CACE-C93C-64294C7E9AD8}"/>
+              </a:ext>
+            </a:extLst>
+          </p:cNvPr>
+          <p:cNvPicPr>
+            <a:picLocks noChangeAspect="1"/>
+          </p:cNvPicPr>
+          <p:nvPr>
+            <a:audioFile r:link="rId2"/>
+            <p:extLst>
+              <p:ext uri="{DAA4B4D4-6D71-4841-9C94-3DE7FCFB9230}">
+                <p14:media xmlns:p14="http://schemas.microsoft.com/office/powerpoint/2010/main" r:embed="rId1"/>
+              </p:ext>
+            </p:extLst>
+          </p:nvPr>
+        </p:nvPicPr>
+        <p:blipFill>
+          <a:blip r:embed="rId5"/>
+          <a:stretch>
+            <a:fillRect/>
+          </a:stretch>
+        </p:blipFill>
+        <p:spPr>
+          <a:xfrm>
+            <a:off x="11163300" y="5829300"/>
+            <a:ext cx="812800" cy="812800"/>
+          </a:xfrm>
+          <a:prstGeom prst="rect">
+            <a:avLst/>
+          </a:prstGeom>
+        </p:spPr>
+      </p:pic>
     </p:spTree>
     <p:extLst>
       <p:ext uri="{BB962C8B-B14F-4D97-AF65-F5344CB8AC3E}">
@@ -5160,6 +5658,101 @@
   <p:clrMapOvr>
     <a:masterClrMapping/>
   </p:clrMapOvr>
+  <mc:AlternateContent xmlns:mc="http://schemas.openxmlformats.org/markup-compatibility/2006">
+    <mc:Choice xmlns:p14="http://schemas.microsoft.com/office/powerpoint/2010/main" Requires="p14">
+      <p:transition spd="slow" p14:dur="2000" advTm="14626"/>
+    </mc:Choice>
+    <mc:Fallback>
+      <p:transition spd="slow" advTm="14626"/>
+    </mc:Fallback>
+  </mc:AlternateContent>
+  <p:timing>
+    <p:tnLst>
+      <p:par>
+        <p:cTn id="1" dur="indefinite" restart="never" nodeType="tmRoot">
+          <p:childTnLst>
+            <p:seq concurrent="1" nextAc="seek">
+              <p:cTn id="2" dur="indefinite" nodeType="mainSeq">
+                <p:childTnLst>
+                  <p:par>
+                    <p:cTn id="3" fill="hold">
+                      <p:stCondLst>
+                        <p:cond delay="indefinite"/>
+                        <p:cond evt="onBegin" delay="0">
+                          <p:tn val="2"/>
+                        </p:cond>
+                      </p:stCondLst>
+                      <p:childTnLst>
+                        <p:par>
+                          <p:cTn id="4" fill="hold">
+                            <p:stCondLst>
+                              <p:cond delay="0"/>
+                            </p:stCondLst>
+                            <p:childTnLst>
+                              <p:par>
+                                <p:cTn id="5" presetID="1" presetClass="mediacall" presetSubtype="0" fill="hold" nodeType="afterEffect">
+                                  <p:stCondLst>
+                                    <p:cond delay="0"/>
+                                  </p:stCondLst>
+                                  <p:childTnLst>
+                                    <p:cmd type="call" cmd="playFrom(0.0)">
+                                      <p:cBhvr>
+                                        <p:cTn id="6" dur="1" fill="hold"/>
+                                        <p:tgtEl>
+                                          <p:spTgt spid="18"/>
+                                        </p:tgtEl>
+                                      </p:cBhvr>
+                                    </p:cmd>
+                                  </p:childTnLst>
+                                </p:cTn>
+                              </p:par>
+                            </p:childTnLst>
+                          </p:cTn>
+                        </p:par>
+                      </p:childTnLst>
+                    </p:cTn>
+                  </p:par>
+                </p:childTnLst>
+              </p:cTn>
+              <p:prevCondLst>
+                <p:cond evt="onPrev" delay="0">
+                  <p:tgtEl>
+                    <p:sldTgt/>
+                  </p:tgtEl>
+                </p:cond>
+              </p:prevCondLst>
+              <p:nextCondLst>
+                <p:cond evt="onNext" delay="0">
+                  <p:tgtEl>
+                    <p:sldTgt/>
+                  </p:tgtEl>
+                </p:cond>
+              </p:nextCondLst>
+            </p:seq>
+            <p:audio isNarration="1">
+              <p:cMediaNode vol="80000" showWhenStopped="0">
+                <p:cTn id="7" fill="hold" display="0">
+                  <p:stCondLst>
+                    <p:cond delay="indefinite"/>
+                  </p:stCondLst>
+                  <p:endCondLst>
+                    <p:cond evt="onStopAudio" delay="0">
+                      <p:tgtEl>
+                        <p:sldTgt/>
+                      </p:tgtEl>
+                    </p:cond>
+                  </p:endCondLst>
+                </p:cTn>
+                <p:tgtEl>
+                  <p:spTgt spid="18"/>
+                </p:tgtEl>
+              </p:cMediaNode>
+            </p:audio>
+          </p:childTnLst>
+        </p:cTn>
+      </p:par>
+    </p:tnLst>
+  </p:timing>
 </p:sld>
 </file>
 
@@ -6185,6 +6778,43 @@
           </a:p>
         </p:txBody>
       </p:sp>
+      <p:pic>
+        <p:nvPicPr>
+          <p:cNvPr id="22" name="Audio 21">
+            <a:extLst>
+              <a:ext uri="{FF2B5EF4-FFF2-40B4-BE49-F238E27FC236}">
+                <a16:creationId xmlns:a16="http://schemas.microsoft.com/office/drawing/2014/main" id="{816A5532-09E7-F115-90A6-7D66631F705C}"/>
+              </a:ext>
+            </a:extLst>
+          </p:cNvPr>
+          <p:cNvPicPr>
+            <a:picLocks noChangeAspect="1"/>
+          </p:cNvPicPr>
+          <p:nvPr>
+            <a:audioFile r:link="rId2"/>
+            <p:extLst>
+              <p:ext uri="{DAA4B4D4-6D71-4841-9C94-3DE7FCFB9230}">
+                <p14:media xmlns:p14="http://schemas.microsoft.com/office/powerpoint/2010/main" r:embed="rId1"/>
+              </p:ext>
+            </p:extLst>
+          </p:nvPr>
+        </p:nvPicPr>
+        <p:blipFill>
+          <a:blip r:embed="rId5"/>
+          <a:stretch>
+            <a:fillRect/>
+          </a:stretch>
+        </p:blipFill>
+        <p:spPr>
+          <a:xfrm>
+            <a:off x="11163300" y="5829300"/>
+            <a:ext cx="812800" cy="812800"/>
+          </a:xfrm>
+          <a:prstGeom prst="rect">
+            <a:avLst/>
+          </a:prstGeom>
+        </p:spPr>
+      </p:pic>
     </p:spTree>
     <p:extLst>
       <p:ext uri="{BB962C8B-B14F-4D97-AF65-F5344CB8AC3E}">
@@ -6195,6 +6825,101 @@
   <p:clrMapOvr>
     <a:masterClrMapping/>
   </p:clrMapOvr>
+  <mc:AlternateContent xmlns:mc="http://schemas.openxmlformats.org/markup-compatibility/2006">
+    <mc:Choice xmlns:p14="http://schemas.microsoft.com/office/powerpoint/2010/main" Requires="p14">
+      <p:transition spd="slow" p14:dur="2000" advTm="12025"/>
+    </mc:Choice>
+    <mc:Fallback>
+      <p:transition spd="slow" advTm="12025"/>
+    </mc:Fallback>
+  </mc:AlternateContent>
+  <p:timing>
+    <p:tnLst>
+      <p:par>
+        <p:cTn id="1" dur="indefinite" restart="never" nodeType="tmRoot">
+          <p:childTnLst>
+            <p:seq concurrent="1" nextAc="seek">
+              <p:cTn id="2" dur="indefinite" nodeType="mainSeq">
+                <p:childTnLst>
+                  <p:par>
+                    <p:cTn id="3" fill="hold">
+                      <p:stCondLst>
+                        <p:cond delay="indefinite"/>
+                        <p:cond evt="onBegin" delay="0">
+                          <p:tn val="2"/>
+                        </p:cond>
+                      </p:stCondLst>
+                      <p:childTnLst>
+                        <p:par>
+                          <p:cTn id="4" fill="hold">
+                            <p:stCondLst>
+                              <p:cond delay="0"/>
+                            </p:stCondLst>
+                            <p:childTnLst>
+                              <p:par>
+                                <p:cTn id="5" presetID="1" presetClass="mediacall" presetSubtype="0" fill="hold" nodeType="afterEffect">
+                                  <p:stCondLst>
+                                    <p:cond delay="0"/>
+                                  </p:stCondLst>
+                                  <p:childTnLst>
+                                    <p:cmd type="call" cmd="playFrom(0.0)">
+                                      <p:cBhvr>
+                                        <p:cTn id="6" dur="1" fill="hold"/>
+                                        <p:tgtEl>
+                                          <p:spTgt spid="22"/>
+                                        </p:tgtEl>
+                                      </p:cBhvr>
+                                    </p:cmd>
+                                  </p:childTnLst>
+                                </p:cTn>
+                              </p:par>
+                            </p:childTnLst>
+                          </p:cTn>
+                        </p:par>
+                      </p:childTnLst>
+                    </p:cTn>
+                  </p:par>
+                </p:childTnLst>
+              </p:cTn>
+              <p:prevCondLst>
+                <p:cond evt="onPrev" delay="0">
+                  <p:tgtEl>
+                    <p:sldTgt/>
+                  </p:tgtEl>
+                </p:cond>
+              </p:prevCondLst>
+              <p:nextCondLst>
+                <p:cond evt="onNext" delay="0">
+                  <p:tgtEl>
+                    <p:sldTgt/>
+                  </p:tgtEl>
+                </p:cond>
+              </p:nextCondLst>
+            </p:seq>
+            <p:audio isNarration="1">
+              <p:cMediaNode vol="80000" showWhenStopped="0">
+                <p:cTn id="7" fill="hold" display="0">
+                  <p:stCondLst>
+                    <p:cond delay="indefinite"/>
+                  </p:stCondLst>
+                  <p:endCondLst>
+                    <p:cond evt="onStopAudio" delay="0">
+                      <p:tgtEl>
+                        <p:sldTgt/>
+                      </p:tgtEl>
+                    </p:cond>
+                  </p:endCondLst>
+                </p:cTn>
+                <p:tgtEl>
+                  <p:spTgt spid="22"/>
+                </p:tgtEl>
+              </p:cMediaNode>
+            </p:audio>
+          </p:childTnLst>
+        </p:cTn>
+      </p:par>
+    </p:tnLst>
+  </p:timing>
 </p:sld>
 </file>
 
@@ -7255,6 +7980,43 @@
           </a:p>
         </p:txBody>
       </p:sp>
+      <p:pic>
+        <p:nvPicPr>
+          <p:cNvPr id="18" name="Audio 17">
+            <a:extLst>
+              <a:ext uri="{FF2B5EF4-FFF2-40B4-BE49-F238E27FC236}">
+                <a16:creationId xmlns:a16="http://schemas.microsoft.com/office/drawing/2014/main" id="{30987DCE-B220-C682-FE24-3761468D5667}"/>
+              </a:ext>
+            </a:extLst>
+          </p:cNvPr>
+          <p:cNvPicPr>
+            <a:picLocks noChangeAspect="1"/>
+          </p:cNvPicPr>
+          <p:nvPr>
+            <a:audioFile r:link="rId2"/>
+            <p:extLst>
+              <p:ext uri="{DAA4B4D4-6D71-4841-9C94-3DE7FCFB9230}">
+                <p14:media xmlns:p14="http://schemas.microsoft.com/office/powerpoint/2010/main" r:embed="rId1"/>
+              </p:ext>
+            </p:extLst>
+          </p:nvPr>
+        </p:nvPicPr>
+        <p:blipFill>
+          <a:blip r:embed="rId5"/>
+          <a:stretch>
+            <a:fillRect/>
+          </a:stretch>
+        </p:blipFill>
+        <p:spPr>
+          <a:xfrm>
+            <a:off x="11163300" y="5829300"/>
+            <a:ext cx="812800" cy="812800"/>
+          </a:xfrm>
+          <a:prstGeom prst="rect">
+            <a:avLst/>
+          </a:prstGeom>
+        </p:spPr>
+      </p:pic>
     </p:spTree>
     <p:extLst>
       <p:ext uri="{BB962C8B-B14F-4D97-AF65-F5344CB8AC3E}">
@@ -7265,6 +8027,101 @@
   <p:clrMapOvr>
     <a:masterClrMapping/>
   </p:clrMapOvr>
+  <mc:AlternateContent xmlns:mc="http://schemas.openxmlformats.org/markup-compatibility/2006">
+    <mc:Choice xmlns:p14="http://schemas.microsoft.com/office/powerpoint/2010/main" Requires="p14">
+      <p:transition spd="slow" p14:dur="2000" advTm="19216"/>
+    </mc:Choice>
+    <mc:Fallback>
+      <p:transition spd="slow" advTm="19216"/>
+    </mc:Fallback>
+  </mc:AlternateContent>
+  <p:timing>
+    <p:tnLst>
+      <p:par>
+        <p:cTn id="1" dur="indefinite" restart="never" nodeType="tmRoot">
+          <p:childTnLst>
+            <p:seq concurrent="1" nextAc="seek">
+              <p:cTn id="2" dur="indefinite" nodeType="mainSeq">
+                <p:childTnLst>
+                  <p:par>
+                    <p:cTn id="3" fill="hold">
+                      <p:stCondLst>
+                        <p:cond delay="indefinite"/>
+                        <p:cond evt="onBegin" delay="0">
+                          <p:tn val="2"/>
+                        </p:cond>
+                      </p:stCondLst>
+                      <p:childTnLst>
+                        <p:par>
+                          <p:cTn id="4" fill="hold">
+                            <p:stCondLst>
+                              <p:cond delay="0"/>
+                            </p:stCondLst>
+                            <p:childTnLst>
+                              <p:par>
+                                <p:cTn id="5" presetID="1" presetClass="mediacall" presetSubtype="0" fill="hold" nodeType="afterEffect">
+                                  <p:stCondLst>
+                                    <p:cond delay="0"/>
+                                  </p:stCondLst>
+                                  <p:childTnLst>
+                                    <p:cmd type="call" cmd="playFrom(0.0)">
+                                      <p:cBhvr>
+                                        <p:cTn id="6" dur="1" fill="hold"/>
+                                        <p:tgtEl>
+                                          <p:spTgt spid="18"/>
+                                        </p:tgtEl>
+                                      </p:cBhvr>
+                                    </p:cmd>
+                                  </p:childTnLst>
+                                </p:cTn>
+                              </p:par>
+                            </p:childTnLst>
+                          </p:cTn>
+                        </p:par>
+                      </p:childTnLst>
+                    </p:cTn>
+                  </p:par>
+                </p:childTnLst>
+              </p:cTn>
+              <p:prevCondLst>
+                <p:cond evt="onPrev" delay="0">
+                  <p:tgtEl>
+                    <p:sldTgt/>
+                  </p:tgtEl>
+                </p:cond>
+              </p:prevCondLst>
+              <p:nextCondLst>
+                <p:cond evt="onNext" delay="0">
+                  <p:tgtEl>
+                    <p:sldTgt/>
+                  </p:tgtEl>
+                </p:cond>
+              </p:nextCondLst>
+            </p:seq>
+            <p:audio isNarration="1">
+              <p:cMediaNode vol="80000" showWhenStopped="0">
+                <p:cTn id="7" fill="hold" display="0">
+                  <p:stCondLst>
+                    <p:cond delay="indefinite"/>
+                  </p:stCondLst>
+                  <p:endCondLst>
+                    <p:cond evt="onStopAudio" delay="0">
+                      <p:tgtEl>
+                        <p:sldTgt/>
+                      </p:tgtEl>
+                    </p:cond>
+                  </p:endCondLst>
+                </p:cTn>
+                <p:tgtEl>
+                  <p:spTgt spid="18"/>
+                </p:tgtEl>
+              </p:cMediaNode>
+            </p:audio>
+          </p:childTnLst>
+        </p:cTn>
+      </p:par>
+    </p:tnLst>
+  </p:timing>
 </p:sld>
 </file>
 

</xml_diff>